<commit_message>
A/B testing: simpler session code, a Python script version, updated deck
Co-Authored-By: Claude Opus 5.5 <noreply@anthropic.com>
Claude-Session: https://claude.ai/code/session_01TbrdxHn7W6FVXXnpqzNytd
</commit_message>
<xml_diff>
--- a/slides/experiments-and-ab-testing_WT26-27.pptx
+++ b/slides/experiments-and-ab-testing_WT26-27.pptx
@@ -3224,7 +3224,7 @@
           <a:lstStyle/>
           <a:p>
             <a:r>
-              <a:t>One sentence per takeaway. Seeing is not causing: compare random groups, not people who got something with those who did not. A coin flip makes A and B alike, so B − A is the effect; report it in percentage points with its confidence interval. Plan the sample size before the send and check the split before the result. A factorial design tests two changes at once; with an interaction, report the simple effects. Read interactions in percentage points and test a moderator before you claim that the market matters. Next: run ab_testing.qmd from top to bottom; it reproduces every number of the deck.</a:t>
+              <a:t>One sentence per takeaway. Seeing is not causing: compare random groups, not people who got something with those who did not. A coin flip makes A and B alike, so B − A is the effect; report it in percentage points with its confidence interval. Plan the sample size before the send and check the split before the result. A factorial design tests two changes at once; with an interaction, report the simple effects. Read interactions in percentage points and test a moderator before you claim that the market matters. Next: run ab_testing.qmd from top to bottom; it reproduces the results on the slides.</a:t>
             </a:r>
           </a:p>
         </p:txBody>
@@ -49510,7 +49510,7 @@
                   <a:schemeClr val="bg1"/>
                 </a:solidFill>
               </a:rPr>
-              <a:t>run sessions/01-foundations/ab_testing.qmd; it reproduces every number of the deck.</a:t>
+              <a:t>run sessions/01-foundations/ab_testing.qmd (or ab_testing.py); it reproduces the results on the slides.</a:t>
             </a:r>
           </a:p>
         </p:txBody>

</xml_diff>